<commit_message>
Adapt skill for Russian patent applications
</commit_message>
<xml_diff>
--- a/examples/example_batch_job_scheduler/knowledge/docs/sample_scheduler_deck.pptx
+++ b/examples/example_batch_job_scheduler/knowledge/docs/sample_scheduler_deck.pptx
@@ -3108,7 +3108,7 @@
           <a:lstStyle/>
           <a:p>
             <a:r>
-              <a:t>批任务调度方案评审（示例 PPT）</a:t>
+              <a:t>Обзор пакетного планировщика</a:t>
             </a:r>
           </a:p>
         </p:txBody>
@@ -3129,7 +3129,7 @@
           <a:lstStyle/>
           <a:p>
             <a:r>
-              <a:t>虚构示例 · 用于 pptx_to_md 与多模态 Read 演练</a:t>
+              <a:t>Вымышленные материалы для сканирования patent-ru-skill</a:t>
             </a:r>
           </a:p>
         </p:txBody>
@@ -3168,7 +3168,7 @@
           <a:lstStyle/>
           <a:p>
             <a:r>
-              <a:t>痛点</a:t>
+              <a:t>Техническая проблема</a:t>
             </a:r>
           </a:p>
         </p:txBody>
@@ -3188,8 +3188,21 @@
           <a:bodyPr/>
           <a:lstStyle/>
           <a:p>
-            <a:r>
-              <a:t>异构节点资源错配；静态优先级无法反映实时画像；需限频重排队缓解震荡。</a:t>
+            <a:pPr/>
+            <a:r>
+              <a:t>Неоднородные узлы имеют разную CPU, memory и I/O емкость.</a:t>
+            </a:r>
+          </a:p>
+          <a:p>
+            <a:pPr/>
+            <a:r>
+              <a:t>Статический приоритет не отражает доступность ресурсов в реальном времени.</a:t>
+            </a:r>
+          </a:p>
+          <a:p>
+            <a:pPr/>
+            <a:r>
+              <a:t>Слишком частое переупорядочивание может вызывать нестабильность планирования.</a:t>
             </a:r>
           </a:p>
         </p:txBody>
@@ -3212,9 +3225,30 @@
         <p:nvPr/>
       </p:nvGrpSpPr>
       <p:grpSpPr/>
+      <p:sp>
+        <p:nvSpPr>
+          <p:cNvPr id="2" name="Title 1"/>
+          <p:cNvSpPr>
+            <a:spLocks noGrp="1"/>
+          </p:cNvSpPr>
+          <p:nvPr>
+            <p:ph type="title"/>
+          </p:nvPr>
+        </p:nvSpPr>
+        <p:spPr/>
+        <p:txBody>
+          <a:bodyPr/>
+          <a:lstStyle/>
+          <a:p>
+            <a:r>
+              <a:t>Связь модулей</a:t>
+            </a:r>
+          </a:p>
+        </p:txBody>
+      </p:sp>
       <p:pic>
         <p:nvPicPr>
-          <p:cNvPr id="2" name="Picture 1" descr="sample_fig_modules.png"/>
+          <p:cNvPr id="3" name="Picture 2" descr="sample_fig_modules.png"/>
           <p:cNvPicPr>
             <a:picLocks noChangeAspect="1"/>
           </p:cNvPicPr>
@@ -3228,45 +3262,14 @@
         </p:blipFill>
         <p:spPr>
           <a:xfrm>
-            <a:off x="731520" y="1097280"/>
-            <a:ext cx="7772400" cy="4371975"/>
+            <a:off x="914400" y="1371600"/>
+            <a:ext cx="6400800" cy="3600450"/>
           </a:xfrm>
           <a:prstGeom prst="rect">
             <a:avLst/>
           </a:prstGeom>
         </p:spPr>
       </p:pic>
-      <p:sp>
-        <p:nvSpPr>
-          <p:cNvPr id="3" name="TextBox 2"/>
-          <p:cNvSpPr txBox="1"/>
-          <p:nvPr/>
-        </p:nvSpPr>
-        <p:spPr>
-          <a:xfrm>
-            <a:off x="457200" y="320040"/>
-            <a:ext cx="8229600" cy="640080"/>
-          </a:xfrm>
-          <a:prstGeom prst="rect">
-            <a:avLst/>
-          </a:prstGeom>
-          <a:noFill/>
-        </p:spPr>
-        <p:txBody>
-          <a:bodyPr wrap="none">
-            <a:spAutoFit/>
-          </a:bodyPr>
-          <a:lstStyle/>
-          <a:p>
-            <a:pPr>
-              <a:defRPr sz="2000" b="1"/>
-            </a:pPr>
-            <a:r>
-              <a:t>模块关系示意（嵌入图 1）</a:t>
-            </a:r>
-          </a:p>
-        </p:txBody>
-      </p:sp>
     </p:spTree>
   </p:cSld>
   <p:clrMapOvr>
@@ -3285,9 +3288,30 @@
         <p:nvPr/>
       </p:nvGrpSpPr>
       <p:grpSpPr/>
+      <p:sp>
+        <p:nvSpPr>
+          <p:cNvPr id="2" name="Title 1"/>
+          <p:cNvSpPr>
+            <a:spLocks noGrp="1"/>
+          </p:cNvSpPr>
+          <p:nvPr>
+            <p:ph type="title"/>
+          </p:nvPr>
+        </p:nvSpPr>
+        <p:spPr/>
+        <p:txBody>
+          <a:bodyPr/>
+          <a:lstStyle/>
+          <a:p>
+            <a:r>
+              <a:t>Пример окна очереди</a:t>
+            </a:r>
+          </a:p>
+        </p:txBody>
+      </p:sp>
       <p:pic>
         <p:nvPicPr>
-          <p:cNvPr id="2" name="Picture 1" descr="sample_fig_queue.png"/>
+          <p:cNvPr id="3" name="Picture 2" descr="sample_fig_queue.png"/>
           <p:cNvPicPr>
             <a:picLocks noChangeAspect="1"/>
           </p:cNvPicPr>
@@ -3301,45 +3325,14 @@
         </p:blipFill>
         <p:spPr>
           <a:xfrm>
-            <a:off x="731520" y="1097280"/>
-            <a:ext cx="7772400" cy="4371975"/>
+            <a:off x="914400" y="1371600"/>
+            <a:ext cx="6400800" cy="3600450"/>
           </a:xfrm>
           <a:prstGeom prst="rect">
             <a:avLst/>
           </a:prstGeom>
         </p:spPr>
       </p:pic>
-      <p:sp>
-        <p:nvSpPr>
-          <p:cNvPr id="3" name="TextBox 2"/>
-          <p:cNvSpPr txBox="1"/>
-          <p:nvPr/>
-        </p:nvSpPr>
-        <p:spPr>
-          <a:xfrm>
-            <a:off x="457200" y="320040"/>
-            <a:ext cx="8229600" cy="640080"/>
-          </a:xfrm>
-          <a:prstGeom prst="rect">
-            <a:avLst/>
-          </a:prstGeom>
-          <a:noFill/>
-        </p:spPr>
-        <p:txBody>
-          <a:bodyPr wrap="none">
-            <a:spAutoFit/>
-          </a:bodyPr>
-          <a:lstStyle/>
-          <a:p>
-            <a:pPr>
-              <a:defRPr sz="2000" b="1"/>
-            </a:pPr>
-            <a:r>
-              <a:t>队列与异构节点（嵌入图 2）</a:t>
-            </a:r>
-          </a:p>
-        </p:txBody>
-      </p:sp>
     </p:spTree>
   </p:cSld>
   <p:clrMapOvr>
@@ -3374,7 +3367,7 @@
           <a:lstStyle/>
           <a:p>
             <a:r>
-              <a:t>下一步</a:t>
+              <a:t>Заметки для патентного черновика</a:t>
             </a:r>
           </a:p>
         </p:txBody>
@@ -3394,8 +3387,21 @@
           <a:bodyPr/>
           <a:lstStyle/>
           <a:p>
-            <a:r>
-              <a:t>对齐 architecture.md 与 pkg/scheduler 示例代码；进入专利点提炼与交底书草稿。</a:t>
+            <a:pPr/>
+            <a:r>
+              <a:t>Независимый пункт может быть направлен на способ с векторами требований и профилями узлов.</a:t>
+            </a:r>
+          </a:p>
+          <a:p>
+            <a:pPr/>
+            <a:r>
+              <a:t>Зависимые пункты могут раскрывать окно сглаживания, score-пороги и heartbeat-проверку.</a:t>
+            </a:r>
+          </a:p>
+          <a:p>
+            <a:pPr/>
+            <a:r>
+              <a:t>Фигуры могут включать структурную схему системы и блок-схему способа.</a:t>
             </a:r>
           </a:p>
         </p:txBody>
@@ -3456,8 +3462,8 @@
         <a:cs typeface=""/>
         <a:font script="Jpan" typeface="ＭＳ Ｐゴシック"/>
         <a:font script="Hang" typeface="맑은 고딕"/>
-        <a:font script="Hans" typeface="宋体"/>
-        <a:font script="Hant" typeface="新細明體"/>
+        <a:font script="Hans" typeface="Arial"/>
+        <a:font script="Hant" typeface="Arial"/>
         <a:font script="Arab" typeface="Times New Roman"/>
         <a:font script="Hebr" typeface="Times New Roman"/>
         <a:font script="Thai" typeface="Angsana New"/>
@@ -3491,8 +3497,8 @@
         <a:cs typeface=""/>
         <a:font script="Jpan" typeface="ＭＳ Ｐゴシック"/>
         <a:font script="Hang" typeface="맑은 고딕"/>
-        <a:font script="Hans" typeface="宋体"/>
-        <a:font script="Hant" typeface="新細明體"/>
+        <a:font script="Hans" typeface="Arial"/>
+        <a:font script="Hant" typeface="Arial"/>
         <a:font script="Arab" typeface="Arial"/>
         <a:font script="Hebr" typeface="Arial"/>
         <a:font script="Thai" typeface="Cordia New"/>

</xml_diff>